<commit_message>
Embed JetBrains Mono fonts in pitch deck
Embeds Regular and Bold TTFs (OFL-licensed) directly in the PPTX so the
deck renders correctly on machines without the font installed.

Co-Authored-By: Claude Fable 5 <noreply@anthropic.com>
Claude-Session: https://claude.ai/code/session_01MnGUNKFknTWd3NPsjMAgqJ
</commit_message>
<xml_diff>
--- a/docs/presentations/VETTED-pitch-deck.pptx
+++ b/docs/presentations/VETTED-pitch-deck.pptx
@@ -1,6 +1,6 @@
 
 <file path=ppt/presentation.xml><?xml version="1.0" encoding="utf-8"?>
-<p:presentation xmlns:a="http://schemas.openxmlformats.org/drawingml/2006/main" xmlns:r="http://schemas.openxmlformats.org/officeDocument/2006/relationships" xmlns:p="http://schemas.openxmlformats.org/presentationml/2006/main" saveSubsetFonts="1" autoCompressPictures="0">
+<p:presentation xmlns:a="http://schemas.openxmlformats.org/drawingml/2006/main" xmlns:r="http://schemas.openxmlformats.org/officeDocument/2006/relationships" xmlns:p="http://schemas.openxmlformats.org/presentationml/2006/main" saveSubsetFonts="1" autoCompressPictures="0" embedTrueTypeFonts="1">
   <p:sldMasterIdLst>
     <p:sldMasterId id="2147483648" r:id="rId1"/>
   </p:sldMasterIdLst>
@@ -17,6 +17,13 @@
   </p:sldIdLst>
   <p:sldSz cx="12191695" cy="6858000" type="screen4x3"/>
   <p:notesSz cx="6858000" cy="9144000"/>
+  <p:embeddedFontLst>
+    <p:embeddedFont>
+      <p:font typeface="JetBrains Mono"/>
+      <p:regular r:id="rId17"/>
+      <p:bold r:id="rId18"/>
+    </p:embeddedFont>
+  </p:embeddedFontLst>
   <p:defaultTextStyle>
     <a:defPPr>
       <a:defRPr lang="en-US"/>

</xml_diff>